<commit_message>
Update Sporta Zales Grafiks project
</commit_message>
<xml_diff>
--- a/relatedfiles/Gym_Tracker_2.pptx
+++ b/relatedfiles/Gym_Tracker_2.pptx
@@ -150,7 +150,7 @@
 <file path=ppt/revisionInfo.xml><?xml version="1.0" encoding="utf-8"?>
 <p1510:revInfo xmlns:a="http://schemas.openxmlformats.org/drawingml/2006/main" xmlns:r="http://schemas.openxmlformats.org/officeDocument/2006/relationships" xmlns:p1510="http://schemas.microsoft.com/office/powerpoint/2015/10/main">
   <p1510:revLst>
-    <p1510:client id="{ED113259-E160-4C54-A0F9-C6084BC16435}" v="546" dt="2026-06-15T21:39:55.810"/>
+    <p1510:client id="{D8F9B479-2399-45F8-A707-5531B59488C9}" v="2" dt="2026-10-16T12:14:48.991"/>
   </p1510:revLst>
 </p1510:revInfo>
 </file>
@@ -670,7 +670,7 @@
             <a:fld id="{B61BEF0D-F0BB-DE4B-95CE-6DB70DBA9567}" type="datetimeFigureOut">
               <a:rPr lang="en-US" dirty="0"/>
               <a:pPr/>
-              <a:t>6/17/2026</a:t>
+              <a:t>10/16/2026</a:t>
             </a:fld>
             <a:endParaRPr lang="en-US" dirty="0"/>
           </a:p>
@@ -772,7 +772,7 @@
           </a:ln>
           <a:extLst>
             <a:ext uri="{91240B29-F687-4f45-9708-019B960494DF}">
-              <a14:hiddenLine xmlns:a14="http://schemas.microsoft.com/office/drawing/2010/main" xmlns="" w="9525">
+              <a14:hiddenLine xmlns="" xmlns:a14="http://schemas.microsoft.com/office/drawing/2010/main" w="9525">
                 <a:solidFill>
                   <a:srgbClr val="000000"/>
                 </a:solidFill>
@@ -827,7 +827,7 @@
           </a:ln>
           <a:extLst>
             <a:ext uri="{91240B29-F687-4f45-9708-019B960494DF}">
-              <a14:hiddenLine xmlns:a14="http://schemas.microsoft.com/office/drawing/2010/main" xmlns="" w="9525">
+              <a14:hiddenLine xmlns="" xmlns:a14="http://schemas.microsoft.com/office/drawing/2010/main" w="9525">
                 <a:solidFill>
                   <a:srgbClr val="000000"/>
                 </a:solidFill>
@@ -1078,7 +1078,7 @@
             <a:fld id="{B61BEF0D-F0BB-DE4B-95CE-6DB70DBA9567}" type="datetimeFigureOut">
               <a:rPr lang="en-US" dirty="0"/>
               <a:pPr/>
-              <a:t>6/17/2026</a:t>
+              <a:t>10/16/2026</a:t>
             </a:fld>
             <a:endParaRPr lang="en-US" dirty="0"/>
           </a:p>
@@ -1327,7 +1327,7 @@
             <a:fld id="{B61BEF0D-F0BB-DE4B-95CE-6DB70DBA9567}" type="datetimeFigureOut">
               <a:rPr lang="en-US" dirty="0"/>
               <a:pPr/>
-              <a:t>6/17/2026</a:t>
+              <a:t>10/16/2026</a:t>
             </a:fld>
             <a:endParaRPr lang="en-US" dirty="0"/>
           </a:p>
@@ -1868,7 +1868,7 @@
             <a:fld id="{B61BEF0D-F0BB-DE4B-95CE-6DB70DBA9567}" type="datetimeFigureOut">
               <a:rPr lang="en-US" dirty="0"/>
               <a:pPr/>
-              <a:t>6/17/2026</a:t>
+              <a:t>10/16/2026</a:t>
             </a:fld>
             <a:endParaRPr lang="en-US" dirty="0"/>
           </a:p>
@@ -2117,7 +2117,7 @@
             <a:fld id="{B61BEF0D-F0BB-DE4B-95CE-6DB70DBA9567}" type="datetimeFigureOut">
               <a:rPr lang="en-US" dirty="0"/>
               <a:pPr/>
-              <a:t>6/17/2026</a:t>
+              <a:t>10/16/2026</a:t>
             </a:fld>
             <a:endParaRPr lang="en-US" dirty="0"/>
           </a:p>
@@ -2650,7 +2650,7 @@
             <a:fld id="{B61BEF0D-F0BB-DE4B-95CE-6DB70DBA9567}" type="datetimeFigureOut">
               <a:rPr lang="en-US" dirty="0"/>
               <a:pPr/>
-              <a:t>6/17/2026</a:t>
+              <a:t>10/16/2026</a:t>
             </a:fld>
             <a:endParaRPr lang="en-US" dirty="0"/>
           </a:p>
@@ -2948,7 +2948,7 @@
             <a:fld id="{B61BEF0D-F0BB-DE4B-95CE-6DB70DBA9567}" type="datetimeFigureOut">
               <a:rPr lang="en-US" dirty="0"/>
               <a:pPr/>
-              <a:t>6/17/2026</a:t>
+              <a:t>10/16/2026</a:t>
             </a:fld>
             <a:endParaRPr lang="en-US" dirty="0"/>
           </a:p>
@@ -3122,7 +3122,7 @@
             <a:fld id="{B61BEF0D-F0BB-DE4B-95CE-6DB70DBA9567}" type="datetimeFigureOut">
               <a:rPr lang="en-US" dirty="0"/>
               <a:pPr/>
-              <a:t>6/17/2026</a:t>
+              <a:t>10/16/2026</a:t>
             </a:fld>
             <a:endParaRPr lang="en-US" dirty="0"/>
           </a:p>
@@ -3302,7 +3302,7 @@
             <a:fld id="{B61BEF0D-F0BB-DE4B-95CE-6DB70DBA9567}" type="datetimeFigureOut">
               <a:rPr lang="en-US" dirty="0"/>
               <a:pPr/>
-              <a:t>6/17/2026</a:t>
+              <a:t>10/16/2026</a:t>
             </a:fld>
             <a:endParaRPr lang="en-US" dirty="0"/>
           </a:p>
@@ -3487,7 +3487,7 @@
             <a:fld id="{B61BEF0D-F0BB-DE4B-95CE-6DB70DBA9567}" type="datetimeFigureOut">
               <a:rPr lang="en-US" dirty="0"/>
               <a:pPr/>
-              <a:t>6/17/2026</a:t>
+              <a:t>10/16/2026</a:t>
             </a:fld>
             <a:endParaRPr lang="en-US" dirty="0"/>
           </a:p>
@@ -3744,7 +3744,7 @@
             <a:fld id="{B61BEF0D-F0BB-DE4B-95CE-6DB70DBA9567}" type="datetimeFigureOut">
               <a:rPr lang="en-US" dirty="0"/>
               <a:pPr/>
-              <a:t>6/17/2026</a:t>
+              <a:t>10/16/2026</a:t>
             </a:fld>
             <a:endParaRPr lang="en-US" dirty="0"/>
           </a:p>
@@ -4045,7 +4045,7 @@
             <a:fld id="{B61BEF0D-F0BB-DE4B-95CE-6DB70DBA9567}" type="datetimeFigureOut">
               <a:rPr lang="en-US" dirty="0"/>
               <a:pPr/>
-              <a:t>6/17/2026</a:t>
+              <a:t>10/16/2026</a:t>
             </a:fld>
             <a:endParaRPr lang="en-US" dirty="0"/>
           </a:p>
@@ -4486,7 +4486,7 @@
             <a:fld id="{B61BEF0D-F0BB-DE4B-95CE-6DB70DBA9567}" type="datetimeFigureOut">
               <a:rPr lang="en-US" dirty="0"/>
               <a:pPr/>
-              <a:t>6/17/2026</a:t>
+              <a:t>10/16/2026</a:t>
             </a:fld>
             <a:endParaRPr lang="en-US" dirty="0"/>
           </a:p>
@@ -4605,7 +4605,7 @@
             <a:fld id="{B61BEF0D-F0BB-DE4B-95CE-6DB70DBA9567}" type="datetimeFigureOut">
               <a:rPr lang="en-US" dirty="0"/>
               <a:pPr/>
-              <a:t>6/17/2026</a:t>
+              <a:t>10/16/2026</a:t>
             </a:fld>
             <a:endParaRPr lang="en-US" dirty="0"/>
           </a:p>
@@ -4702,7 +4702,7 @@
             <a:fld id="{B61BEF0D-F0BB-DE4B-95CE-6DB70DBA9567}" type="datetimeFigureOut">
               <a:rPr lang="en-US" dirty="0"/>
               <a:pPr/>
-              <a:t>6/17/2026</a:t>
+              <a:t>10/16/2026</a:t>
             </a:fld>
             <a:endParaRPr lang="en-US" dirty="0"/>
           </a:p>
@@ -4985,7 +4985,7 @@
             <a:fld id="{B61BEF0D-F0BB-DE4B-95CE-6DB70DBA9567}" type="datetimeFigureOut">
               <a:rPr lang="en-US" dirty="0"/>
               <a:pPr/>
-              <a:t>6/17/2026</a:t>
+              <a:t>10/16/2026</a:t>
             </a:fld>
             <a:endParaRPr lang="en-US" dirty="0"/>
           </a:p>
@@ -5273,7 +5273,7 @@
             <a:fld id="{B61BEF0D-F0BB-DE4B-95CE-6DB70DBA9567}" type="datetimeFigureOut">
               <a:rPr lang="en-US" dirty="0"/>
               <a:pPr/>
-              <a:t>6/17/2026</a:t>
+              <a:t>10/16/2026</a:t>
             </a:fld>
             <a:endParaRPr lang="en-US" dirty="0"/>
           </a:p>
@@ -5797,7 +5797,7 @@
             <a:fld id="{B61BEF0D-F0BB-DE4B-95CE-6DB70DBA9567}" type="datetimeFigureOut">
               <a:rPr lang="en-US" dirty="0"/>
               <a:pPr/>
-              <a:t>6/17/2026</a:t>
+              <a:t>10/16/2026</a:t>
             </a:fld>
             <a:endParaRPr lang="en-US" dirty="0"/>
           </a:p>
@@ -6801,7 +6801,7 @@
             </a:pPr>
             <a:r>
               <a:rPr sz="1800" dirty="0" err="1"/>
-              <a:t>verify_email.php</a:t>
+              <a:t>verfy_email.php</a:t>
             </a:r>
             <a:r>
               <a:rPr sz="1800" dirty="0"/>
@@ -7381,7 +7381,7 @@
           <a:p>
             <a:r>
               <a:rPr sz="2200" dirty="0" err="1"/>
-              <a:t>save_class.php</a:t>
+              <a:t>api/save_class.php</a:t>
             </a:r>
             <a:endParaRPr sz="2200" dirty="0" err="1">
               <a:ea typeface="Calibri"/>
@@ -7395,7 +7395,7 @@
             </a:r>
             <a:r>
               <a:rPr lang="en-US" sz="2200" dirty="0" err="1"/>
-              <a:t>delete_class.php</a:t>
+              <a:t>api/delete_class.php</a:t>
             </a:r>
             <a:endParaRPr lang="en-US" sz="2200" dirty="0">
               <a:ea typeface="Calibri"/>
@@ -7405,7 +7405,7 @@
           <a:p>
             <a:r>
               <a:rPr sz="2200" dirty="0" err="1"/>
-              <a:t>cancel_reservation.php</a:t>
+              <a:t>api/cancel_reservation.php</a:t>
             </a:r>
             <a:endParaRPr sz="2200" dirty="0" err="1">
               <a:ea typeface="Calibri"/>
@@ -7415,7 +7415,7 @@
           <a:p>
             <a:r>
               <a:rPr sz="2200" dirty="0" err="1"/>
-              <a:t>get_participants.php</a:t>
+              <a:t>api/get_participants.php</a:t>
             </a:r>
             <a:endParaRPr sz="2200" dirty="0" err="1">
               <a:ea typeface="Calibri"/>
@@ -7434,51 +7434,7 @@
             </a:pPr>
             <a:r>
               <a:rPr sz="2200" dirty="0" err="1"/>
-              <a:t>Administratori</a:t>
-            </a:r>
-            <a:r>
-              <a:rPr sz="2200" dirty="0"/>
-              <a:t> un </a:t>
-            </a:r>
-            <a:r>
-              <a:rPr sz="2200" dirty="0" err="1"/>
-              <a:t>treneri</a:t>
-            </a:r>
-            <a:r>
-              <a:rPr sz="2200" dirty="0"/>
-              <a:t> var </a:t>
-            </a:r>
-            <a:r>
-              <a:rPr sz="2200" dirty="0" err="1"/>
-              <a:t>izveidot</a:t>
-            </a:r>
-            <a:r>
-              <a:rPr sz="2200" dirty="0"/>
-              <a:t>, </a:t>
-            </a:r>
-            <a:r>
-              <a:rPr sz="2200" dirty="0" err="1"/>
-              <a:t>rediģēt</a:t>
-            </a:r>
-            <a:r>
-              <a:rPr sz="2200" dirty="0"/>
-              <a:t> un </a:t>
-            </a:r>
-            <a:r>
-              <a:rPr sz="2200" dirty="0" err="1"/>
-              <a:t>dzēst</a:t>
-            </a:r>
-            <a:r>
-              <a:rPr sz="2200" dirty="0"/>
-              <a:t> </a:t>
-            </a:r>
-            <a:r>
-              <a:rPr sz="2200" dirty="0" err="1"/>
-              <a:t>nodarbības</a:t>
-            </a:r>
-            <a:r>
-              <a:rPr sz="2200" dirty="0"/>
-              <a:t>.</a:t>
+              <a:t>Treneri pārvalda savas, administratori – visas nodarbības.</a:t>
             </a:r>
             <a:endParaRPr sz="2200">
               <a:ea typeface="Calibri"/>
@@ -8289,7 +8245,7 @@
           <a:lstStyle/>
           <a:p>
             <a:r>
-              <a:t>11. Reāllaika funkcionalitāte</a:t>
+              <a:t>11. SSE galapunkts</a:t>
             </a:r>
           </a:p>
         </p:txBody>
@@ -8357,39 +8313,7 @@
             </a:pPr>
             <a:r>
               <a:rPr sz="2200" dirty="0" err="1"/>
-              <a:t>Serveris</a:t>
-            </a:r>
-            <a:r>
-              <a:rPr sz="2200" dirty="0"/>
-              <a:t> → SSE </a:t>
-            </a:r>
-            <a:r>
-              <a:rPr sz="2200" dirty="0" err="1"/>
-              <a:t>savienojums</a:t>
-            </a:r>
-            <a:r>
-              <a:rPr sz="2200" dirty="0"/>
-              <a:t> → Jauna </a:t>
-            </a:r>
-            <a:r>
-              <a:rPr sz="2200" dirty="0" err="1"/>
-              <a:t>nodarbība</a:t>
-            </a:r>
-            <a:r>
-              <a:rPr sz="2200" dirty="0"/>
-              <a:t> → </a:t>
-            </a:r>
-            <a:r>
-              <a:rPr sz="2200" dirty="0" err="1"/>
-              <a:t>Tūlītējs</a:t>
-            </a:r>
-            <a:r>
-              <a:rPr sz="2200" dirty="0"/>
-              <a:t> </a:t>
-            </a:r>
-            <a:r>
-              <a:rPr sz="2200" dirty="0" err="1"/>
-              <a:t>atjauninājums</a:t>
+              <a:t>Galapunkts izveidots; kalendāra klients nav pieslēgts</a:t>
             </a:r>
             <a:endParaRPr sz="2200" dirty="0" err="1">
               <a:ea typeface="Calibri"/>
@@ -8408,7 +8332,7 @@
             </a:pPr>
             <a:r>
               <a:rPr sz="2200"/>
-              <a:t>Ieguvumi:</a:t>
+              <a:t>Ierobežojumi:</a:t>
             </a:r>
             <a:endParaRPr sz="2200" dirty="0">
               <a:ea typeface="Calibri"/>
@@ -8418,19 +8342,7 @@
           <a:p>
             <a:r>
               <a:rPr sz="2200" dirty="0"/>
-              <a:t>Nav </a:t>
-            </a:r>
-            <a:r>
-              <a:rPr sz="2200" dirty="0" err="1"/>
-              <a:t>jāpārlādē</a:t>
-            </a:r>
-            <a:r>
-              <a:rPr sz="2200" dirty="0"/>
-              <a:t> </a:t>
-            </a:r>
-            <a:r>
-              <a:rPr sz="2200" dirty="0" err="1"/>
-              <a:t>lapa</a:t>
+              <a:t>Kalendārs SSE neizmanto</a:t>
             </a:r>
             <a:endParaRPr sz="2200" dirty="0" err="1">
               <a:ea typeface="Calibri"/>
@@ -8440,15 +8352,7 @@
           <a:p>
             <a:r>
               <a:rPr sz="2200" dirty="0" err="1"/>
-              <a:t>Ātrāka</a:t>
-            </a:r>
-            <a:r>
-              <a:rPr sz="2200" dirty="0"/>
-              <a:t> datu </a:t>
-            </a:r>
-            <a:r>
-              <a:rPr sz="2200" dirty="0" err="1"/>
-              <a:t>sinhronizācija</a:t>
+              <a:t>Automātiski atjauninājumi nenotiek</a:t>
             </a:r>
             <a:endParaRPr sz="2200" dirty="0" err="1">
               <a:ea typeface="Calibri"/>
@@ -11125,23 +11029,7 @@
           <a:p>
             <a:r>
               <a:rPr sz="2200" dirty="0" err="1"/>
-              <a:t>Administrēt</a:t>
-            </a:r>
-            <a:r>
-              <a:rPr sz="2200" dirty="0"/>
-              <a:t> </a:t>
-            </a:r>
-            <a:r>
-              <a:rPr sz="2200" dirty="0" err="1"/>
-              <a:t>trenerus</a:t>
-            </a:r>
-            <a:r>
-              <a:rPr sz="2200" dirty="0"/>
-              <a:t> un </a:t>
-            </a:r>
-            <a:r>
-              <a:rPr sz="2200" dirty="0" err="1"/>
-              <a:t>lietotājus</a:t>
+              <a:t>Administrēt lomas un lietotājus</a:t>
             </a:r>
             <a:endParaRPr sz="2200">
               <a:ea typeface="Calibri"/>
@@ -11177,15 +11065,7 @@
           <a:p>
             <a:r>
               <a:rPr sz="2200" dirty="0" err="1"/>
-              <a:t>Saņemt</a:t>
-            </a:r>
-            <a:r>
-              <a:rPr sz="2200" dirty="0"/>
-              <a:t> e-pasta </a:t>
-            </a:r>
-            <a:r>
-              <a:rPr sz="2200" dirty="0" err="1"/>
-              <a:t>paziņojumus</a:t>
+              <a:t>Saņemt e-pastus</a:t>
             </a:r>
             <a:endParaRPr sz="2200">
               <a:ea typeface="Calibri"/>
@@ -12417,7 +12297,7 @@
           <a:p>
             <a:r>
               <a:rPr sz="2200" dirty="0" err="1"/>
-              <a:t>export_class_participants.php</a:t>
+              <a:t>export/export_class_participants.php</a:t>
             </a:r>
             <a:endParaRPr sz="2200" dirty="0" err="1">
               <a:ea typeface="Calibri"/>
@@ -12427,7 +12307,7 @@
           <a:p>
             <a:r>
               <a:rPr sz="2200" dirty="0" err="1"/>
-              <a:t>export_class_participants_pdf.php</a:t>
+              <a:t>export/export_class_participants_pdf.php</a:t>
             </a:r>
             <a:endParaRPr sz="2200" dirty="0" err="1">
               <a:ea typeface="Calibri"/>
@@ -12446,19 +12326,7 @@
             </a:pPr>
             <a:r>
               <a:rPr sz="2200" dirty="0" err="1"/>
-              <a:t>Atbalstītie</a:t>
-            </a:r>
-            <a:r>
-              <a:rPr sz="2200" dirty="0"/>
-              <a:t> </a:t>
-            </a:r>
-            <a:r>
-              <a:rPr sz="2200" dirty="0" err="1"/>
-              <a:t>formāti</a:t>
-            </a:r>
-            <a:r>
-              <a:rPr sz="2200" dirty="0"/>
-              <a:t>:</a:t>
+              <a:t>Administratora eksports:</a:t>
             </a:r>
             <a:endParaRPr sz="2200" dirty="0">
               <a:ea typeface="Calibri"/>
@@ -12468,15 +12336,7 @@
           <a:p>
             <a:r>
               <a:rPr sz="2200" dirty="0"/>
-              <a:t>CSV (Excel </a:t>
-            </a:r>
-            <a:r>
-              <a:rPr sz="2200" dirty="0" err="1"/>
-              <a:t>savietojamība</a:t>
-            </a:r>
-            <a:r>
-              <a:rPr sz="2200" dirty="0"/>
-              <a:t>)</a:t>
+              <a:t>Excel (.xlsx)</a:t>
             </a:r>
             <a:endParaRPr sz="2200" dirty="0">
               <a:ea typeface="Calibri"/>
@@ -13959,7 +13819,7 @@
             </a:r>
             <a:r>
               <a:rPr sz="2200" dirty="0" err="1"/>
-              <a:t>pilnvērtīga</a:t>
+              <a:t>funkcionāla</a:t>
             </a:r>
             <a:r>
               <a:rPr sz="2200" dirty="0"/>
@@ -14137,19 +13997,7 @@
           <a:p>
             <a:r>
               <a:rPr sz="2200" dirty="0"/>
-              <a:t>✓ </a:t>
-            </a:r>
-            <a:r>
-              <a:rPr sz="2200" dirty="0" err="1"/>
-              <a:t>Reāllaika</a:t>
-            </a:r>
-            <a:r>
-              <a:rPr sz="2200" dirty="0"/>
-              <a:t> </a:t>
-            </a:r>
-            <a:r>
-              <a:rPr sz="2200" dirty="0" err="1"/>
-              <a:t>atjauninājumiem</a:t>
+              <a:t>! SSE un Stripe vēl nav integrēti</a:t>
             </a:r>
             <a:endParaRPr sz="2200" dirty="0">
               <a:ea typeface="Calibri"/>
@@ -14159,19 +14007,7 @@
           <a:p>
             <a:r>
               <a:rPr sz="2200" dirty="0"/>
-              <a:t>✓ CSV </a:t>
-            </a:r>
-            <a:r>
-              <a:rPr sz="2200" dirty="0" err="1"/>
-              <a:t>un PDF</a:t>
-            </a:r>
-            <a:r>
-              <a:rPr sz="2200" dirty="0"/>
-              <a:t> </a:t>
-            </a:r>
-            <a:r>
-              <a:rPr sz="2200" dirty="0" err="1"/>
-              <a:t>eksportu</a:t>
+              <a:t>✓ Excel (.xlsx) un PDF eksportu</a:t>
             </a:r>
             <a:endParaRPr sz="2200" dirty="0">
               <a:ea typeface="Calibri"/>
@@ -14296,6 +14132,13 @@
                 <a:cs typeface="Calibri"/>
               </a:rPr>
               <a:t>uzmanību</a:t>
+            </a:r>
+            <a:r>
+              <a:rPr lang="en-US" dirty="0">
+                <a:ea typeface="Calibri"/>
+                <a:cs typeface="Calibri"/>
+              </a:rPr>
+              <a:t>!</a:t>
             </a:r>
             <a:endParaRPr lang="en-US" dirty="0" err="1"/>
           </a:p>
@@ -14782,7 +14625,7 @@
             </a:pPr>
             <a:r>
               <a:rPr sz="2200" dirty="0" err="1"/>
-              <a:t>Router.php</a:t>
+              <a:t>router.php</a:t>
             </a:r>
             <a:r>
               <a:rPr sz="2200" dirty="0"/>
@@ -15524,7 +15367,7 @@
             </a:r>
             <a:r>
               <a:rPr sz="2200" dirty="0" err="1"/>
-              <a:t>šifrēšana</a:t>
+              <a:t>hashēšana</a:t>
             </a:r>
             <a:endParaRPr sz="2200">
               <a:ea typeface="Calibri"/>
@@ -16013,7 +15856,7 @@
             </a:r>
             <a:r>
               <a:rPr sz="2200" dirty="0" err="1"/>
-              <a:t>šifrēšana</a:t>
+              <a:t>hashēšana</a:t>
             </a:r>
             <a:endParaRPr sz="2200" dirty="0" err="1">
               <a:ea typeface="Calibri"/>

</xml_diff>